<commit_message>
report: polish LaTeX output and refresh assets
</commit_message>
<xml_diff>
--- a/presentation/final_presentation.pptx
+++ b/presentation/final_presentation.pptx
@@ -3594,7 +3594,7 @@
         <p:spPr>
           <a:xfrm>
             <a:off x="548640" y="1645920"/>
-            <a:ext cx="8046720" cy="5588000"/>
+            <a:ext cx="8046720" cy="5532120"/>
           </a:xfrm>
           <a:prstGeom prst="rect">
             <a:avLst/>
@@ -3678,7 +3678,7 @@
         <p:spPr>
           <a:xfrm>
             <a:off x="548640" y="1645920"/>
-            <a:ext cx="8046720" cy="5588000"/>
+            <a:ext cx="8046720" cy="5532120"/>
           </a:xfrm>
           <a:prstGeom prst="rect">
             <a:avLst/>
@@ -3762,7 +3762,7 @@
         <p:spPr>
           <a:xfrm>
             <a:off x="548640" y="1645920"/>
-            <a:ext cx="8046720" cy="4023360"/>
+            <a:ext cx="8046720" cy="4172373"/>
           </a:xfrm>
           <a:prstGeom prst="rect">
             <a:avLst/>

</xml_diff>